<commit_message>
海报截图带: LOOK 的 loop 改由红字承担 (left the form → back on frame 1)
user 希望离开表单那一帧的动作是 back。数据里没有这个事件: LOOK 全程只按过
两次 back (step 6 和 8), 两次都是从新建页退回编辑表单, 造成的画面都是那张
填好的表单, 不是 My listings。

硬换 back 方案 (动作步 [2,5,8]) 的实测代价: 帧2 vs 帧1 只差 2.78, 三帧会
看起来雷同 —— 正是 item_add/item_edit 同模板那个坑。采用的方案是 14.25。

所以保留原帧, loop 由两条红字承担: 帧2 `left the form` · 帧3 `back on frame 1`。
动作类型保持诚实 (都是 click), 红字描述的是位置变化。

Co-Authored-By: Claude Opus 5 (1M context) <noreply@anthropic.com>
Claude-Session: https://claude.ai/code/session_011ujAKgSdpryKn6hcpqHp3o
</commit_message>
<xml_diff>
--- a/deliverables/showcase/poster_v9_jiaming_wei.pptx
+++ b/deliverables/showcase/poster_v9_jiaming_wei.pptx
@@ -5439,11 +5439,20 @@
             <a:r>
               <a:rPr sz="1400" b="0" i="0">
                 <a:solidFill>
-                  <a:srgbClr val="5D6787"/>
+                  <a:srgbClr val="C2352B"/>
                 </a:solidFill>
                 <a:latin typeface="Arial"/>
               </a:rPr>
-              <a:t>$0.071 spent</a:t>
+              <a:t>$0.071 · </a:t>
+            </a:r>
+            <a:r>
+              <a:rPr sz="1400" b="1" i="0">
+                <a:solidFill>
+                  <a:srgbClr val="C2352B"/>
+                </a:solidFill>
+                <a:latin typeface="Arial"/>
+              </a:rPr>
+              <a:t>left the form</a:t>
             </a:r>
           </a:p>
         </p:txBody>

</xml_diff>

<commit_message>
Showcase 海报 v9.9 final pass: 去掉残留的 paper-figure 措辞
四刀 + 一个标题 (user 定的收尾清单):
· panel 5 标题 SO CHOOSE PER TASK? → SO BUILD A ROUTER? NOT SO FAST.
  —— 这格回答的是能不能造出路由器, 「要不要按任务选」已由 1-4 回答完
· panel 5 caption → Only the hindsight oracle enters the win region.
  —— 原句 the lone square 会让读者去图里找哪个 square, 而图里方块很多
· panel 4 基准线 as often as it fails anywhere → 1× overall failure rate
· READ/LOOK 总结压成 Same start. READ finishes; LOOK loops back.
  —— loops back 接上 panel 4 已建立的 action loop 词汇
· panel 6 轴: best single-view coverage (%) / usable routing labels
· panel 4 标签 visual state unseen → missing visual state

顺带两个裁切: VENN_KEEP 定在 0.363 (0.34 切掉 B0 圈注半截, 0.375 带进 B1
标题 —— 同一参数两边都错, 中间那段才对, 只能看渲染找); venn 比例随之
1.83:1, scale 重算 0.899 仍是 82mm。panel 6 的 y 轴竖排后几乎与 axes 等长
被裁, 字号降到 15.5。

明确不再动: heatmap 尺寸 · Venn 内部 metadata · 面积分配 · 六图数量 · 结论。

Co-Authored-By: Claude Opus 5 (1M context) <noreply@anthropic.com>
Claude-Session: https://claude.ai/code/session_011ujAKgSdpryKn6hcpqHp3o
</commit_message>
<xml_diff>
--- a/deliverables/showcase/poster_v9_jiaming_wei.pptx
+++ b/deliverables/showcase/poster_v9_jiaming_wei.pptx
@@ -5655,7 +5655,7 @@
                 </a:solidFill>
                 <a:latin typeface="Arial"/>
               </a:rPr>
-              <a:t>Both start on the same form.</a:t>
+              <a:t>Same start. READ finishes; LOOK loops back.</a:t>
             </a:r>
             <a:r>
               <a:rPr sz="1550" b="0" i="0">
@@ -5664,25 +5664,7 @@
                 </a:solidFill>
                 <a:latin typeface="Arial"/>
               </a:rPr>
-              <a:t> Then READ finishes it, while </a:t>
-            </a:r>
-            <a:r>
-              <a:rPr sz="1550" b="1" i="0">
-                <a:solidFill>
-                  <a:srgbClr val="12162E"/>
-                </a:solidFill>
-                <a:latin typeface="Arial"/>
-              </a:rPr>
-              <a:t>LOOK ends up back on the page it started from</a:t>
-            </a:r>
-            <a:r>
-              <a:rPr sz="1550" b="0" i="0">
-                <a:solidFill>
-                  <a:srgbClr val="12162E"/>
-                </a:solidFill>
-                <a:latin typeface="Arial"/>
-              </a:rPr>
-              <a:t>. One recorded run per view; both outcomes repeat on an independent rerun.</a:t>
+              <a:t> Both outcomes repeat on an independent rerun.</a:t>
             </a:r>
           </a:p>
         </p:txBody>
@@ -6169,8 +6151,8 @@
         </p:nvSpPr>
         <p:spPr>
           <a:xfrm>
-            <a:off x="8050896" y="19515970"/>
-            <a:ext cx="5419008" cy="3277303"/>
+            <a:off x="7860586" y="19515970"/>
+            <a:ext cx="5799628" cy="3284089"/>
           </a:xfrm>
           <a:prstGeom prst="rect">
             <a:avLst/>
@@ -6215,8 +6197,8 @@
         </p:nvSpPr>
         <p:spPr>
           <a:xfrm>
-            <a:off x="8050896" y="19515970"/>
-            <a:ext cx="5419008" cy="50400"/>
+            <a:off x="7860586" y="19515970"/>
+            <a:ext cx="5799628" cy="50400"/>
           </a:xfrm>
           <a:prstGeom prst="rect">
             <a:avLst/>
@@ -6267,8 +6249,8 @@
         </p:blipFill>
         <p:spPr>
           <a:xfrm>
-            <a:off x="8122896" y="19638370"/>
-            <a:ext cx="5275008" cy="3082904"/>
+            <a:off x="7932586" y="19638370"/>
+            <a:ext cx="5655628" cy="3089689"/>
           </a:xfrm>
           <a:prstGeom prst="rect">
             <a:avLst/>
@@ -6283,7 +6265,7 @@
         </p:nvSpPr>
         <p:spPr>
           <a:xfrm>
-            <a:off x="7534800" y="22865273"/>
+            <a:off x="7534800" y="22872059"/>
             <a:ext cx="6451200" cy="279806"/>
           </a:xfrm>
           <a:prstGeom prst="rect">
@@ -6842,7 +6824,7 @@
         <p:spPr>
           <a:xfrm>
             <a:off x="727200" y="24111414"/>
-            <a:ext cx="6451200" cy="2979118"/>
+            <a:ext cx="6451200" cy="2974935"/>
           </a:xfrm>
           <a:prstGeom prst="rect">
             <a:avLst/>
@@ -6940,7 +6922,7 @@
         <p:spPr>
           <a:xfrm>
             <a:off x="799200" y="24233814"/>
-            <a:ext cx="6307200" cy="2784718"/>
+            <a:ext cx="6307200" cy="2780536"/>
           </a:xfrm>
           <a:prstGeom prst="rect">
             <a:avLst/>
@@ -6955,7 +6937,7 @@
         </p:nvSpPr>
         <p:spPr>
           <a:xfrm>
-            <a:off x="727200" y="27162532"/>
+            <a:off x="727200" y="27158349"/>
             <a:ext cx="6451200" cy="559612"/>
           </a:xfrm>
           <a:prstGeom prst="rect">
@@ -7068,7 +7050,7 @@
                 </a:solidFill>
                 <a:latin typeface="Consolas"/>
               </a:rPr>
-              <a:t>5 · SO CHOOSE PER TASK? NOT SO FAST.</a:t>
+              <a:t>5 · SO BUILD A ROUTER? NOT SO FAST.</a:t>
             </a:r>
             <a:endParaRPr sz="1412" b="1" spc="180" dirty="0">
               <a:solidFill>
@@ -7292,7 +7274,7 @@
         <p:spPr>
           <a:xfrm>
             <a:off x="7534800" y="27186959"/>
-            <a:ext cx="6451200" cy="559612"/>
+            <a:ext cx="6451200" cy="279806"/>
           </a:xfrm>
           <a:prstGeom prst="rect">
             <a:avLst/>
@@ -7320,7 +7302,7 @@
                 </a:solidFill>
                 <a:latin typeface="Arial"/>
               </a:rPr>
-              <a:t>No learned policy enters the win region; the lone square is hindsight.</a:t>
+              <a:t>Only the hindsight oracle enters the win region.</a:t>
             </a:r>
           </a:p>
         </p:txBody>

</xml_diff>

<commit_message>
Showcase 海报 v9.10: 让 Panel 5 自己解释自己 + Panel 1 标题改成 finding
user 判据: 第五张图我本人都要重新问它是什么意思, 路过观众更不可能 3 秒读懂。

Panel 5 四个方向全标出来 —— 之前读者得先重建基准线位置、x 轴正负、绿区凭什么
是赢, 才能理解任何一个点:
· x 轴 change in cost vs always-cheapest + ← cheaper / more expensive →
· y 轴 success change (pp) + ↑ more successful
· caption 改成 Learned routers buy success only by spending more; only the
  hindsight oracle reaches the win region.
  —— 旧句只解释绿区为什么空, 没解释那堆橙点在说什么: 学到的路由器不是没提升,
  是提升全靠多花钱

Panel 1 标题 SIX VIEWS, EIGHT SETTINGS → NO VIEW WINS EVERYWHERE。其余五个标题
都在讲发现, 只有它在讲做了什么。改完六个标题连成一条线。

两处没改及原因:
· Panel 6 y 轴不能加 (%) —— 那是绝对计数 (每格 15-97 行, 共 260), 不是比例,
  加百分号会把计数说成占比
· Panel 2 Venn 的 N solved= 等文字画在 matplotlib 图里, 后期删不掉, 要改上游
  脚本并重跑数据管线, 按 user 口径「麻烦就算了」

坑: 旋转 y 轴标签的可用长度受 axes 高度约束而非 figure 高度, 这轮为此裁了两次。

Co-Authored-By: Claude Opus 5 (1M context) <noreply@anthropic.com>
Claude-Session: https://claude.ai/code/session_011ujAKgSdpryKn6hcpqHp3o
</commit_message>
<xml_diff>
--- a/deliverables/showcase/poster_v9_jiaming_wei.pptx
+++ b/deliverables/showcase/poster_v9_jiaming_wei.pptx
@@ -5748,7 +5748,7 @@
                 </a:solidFill>
                 <a:latin typeface="Consolas"/>
               </a:rPr>
-              <a:t>1 · SIX VIEWS, EIGHT SETTINGS</a:t>
+              <a:t>1 · NO VIEW WINS EVERYWHERE</a:t>
             </a:r>
             <a:endParaRPr sz="1412" b="1" spc="180" dirty="0">
               <a:solidFill>
@@ -7160,7 +7160,7 @@
         <p:spPr>
           <a:xfrm>
             <a:off x="7618666" y="24111414"/>
-            <a:ext cx="6283468" cy="3003545"/>
+            <a:ext cx="6283468" cy="3068079"/>
           </a:xfrm>
           <a:prstGeom prst="rect">
             <a:avLst/>
@@ -7258,7 +7258,7 @@
         <p:spPr>
           <a:xfrm>
             <a:off x="7690666" y="24233814"/>
-            <a:ext cx="6139468" cy="2809145"/>
+            <a:ext cx="6139468" cy="2873679"/>
           </a:xfrm>
           <a:prstGeom prst="rect">
             <a:avLst/>
@@ -7273,8 +7273,8 @@
         </p:nvSpPr>
         <p:spPr>
           <a:xfrm>
-            <a:off x="7534800" y="27186959"/>
-            <a:ext cx="6451200" cy="279806"/>
+            <a:off x="7534800" y="27251493"/>
+            <a:ext cx="6451200" cy="559612"/>
           </a:xfrm>
           <a:prstGeom prst="rect">
             <a:avLst/>
@@ -7302,7 +7302,7 @@
                 </a:solidFill>
                 <a:latin typeface="Arial"/>
               </a:rPr>
-              <a:t>Only the hindsight oracle enters the win region.</a:t>
+              <a:t>Learned routers buy success only by spending more; only the hindsight oracle reaches the win region.</a:t>
             </a:r>
           </a:p>
         </p:txBody>

</xml_diff>